<commit_message>
fix (1.2): shorten mercado de dinero y capitales header
</commit_message>
<xml_diff>
--- a/notas_unidades/unidad1/2_mercado_dinero_capitales.pptx
+++ b/notas_unidades/unidad1/2_mercado_dinero_capitales.pptx
@@ -3248,7 +3248,7 @@
                 </a:solidFill>
                 <a:latin typeface="Cambria"/>
               </a:rPr>
-              <a:t>Mercado de Dinero y Mercado de Capitales</a:t>
+              <a:t>Mercado de Dinero y Capitales</a:t>
             </a:r>
           </a:p>
         </p:txBody>
@@ -3336,7 +3336,7 @@
                 </a:solidFill>
                 <a:latin typeface="Calibri"/>
               </a:rPr>
-              <a:t>MERCADO DE DINERO Y MERCADO DE CAPITALES</a:t>
+              <a:t>MERCADO DE DINERO Y CAPITALES</a:t>
             </a:r>
           </a:p>
         </p:txBody>
@@ -3908,7 +3908,7 @@
                 </a:solidFill>
                 <a:latin typeface="Calibri"/>
               </a:rPr>
-              <a:t>MERCADO DE DINERO Y MERCADO DE CAPITALES</a:t>
+              <a:t>MERCADO DE DINERO Y CAPITALES</a:t>
             </a:r>
           </a:p>
         </p:txBody>
@@ -4457,7 +4457,7 @@
                 </a:solidFill>
                 <a:latin typeface="Calibri"/>
               </a:rPr>
-              <a:t>MERCADO DE DINERO Y MERCADO DE CAPITALES</a:t>
+              <a:t>MERCADO DE DINERO Y CAPITALES</a:t>
             </a:r>
           </a:p>
         </p:txBody>
@@ -5321,7 +5321,7 @@
                 </a:solidFill>
                 <a:latin typeface="Calibri"/>
               </a:rPr>
-              <a:t>MERCADO DE DINERO Y MERCADO DE CAPITALES</a:t>
+              <a:t>MERCADO DE DINERO Y CAPITALES</a:t>
             </a:r>
           </a:p>
         </p:txBody>
@@ -6003,7 +6003,7 @@
                 </a:solidFill>
                 <a:latin typeface="Cambria"/>
               </a:rPr>
-              <a:t>Cierre · Mercado de Dinero y Mercado de Capitales</a:t>
+              <a:t>Cierre · Mercado de Dinero y Capitales</a:t>
             </a:r>
           </a:p>
         </p:txBody>

</xml_diff>